<commit_message>
Slider- Some fixings and improvement in CRUD
</commit_message>
<xml_diff>
--- a/.lessons/54 Slider Features/10 Slider- Some fixings and improvement in CRUD/1.pptx
+++ b/.lessons/54 Slider Features/10 Slider- Some fixings and improvement in CRUD/1.pptx
@@ -5,9 +5,14 @@
     <p:sldMasterId id="2147483648" r:id="rId1"/>
   </p:sldMasterIdLst>
   <p:sldIdLst>
-    <p:sldId id="413" r:id="rId2"/>
-    <p:sldId id="414" r:id="rId3"/>
-    <p:sldId id="400" r:id="rId4"/>
+    <p:sldId id="414" r:id="rId2"/>
+    <p:sldId id="413" r:id="rId3"/>
+    <p:sldId id="415" r:id="rId4"/>
+    <p:sldId id="416" r:id="rId5"/>
+    <p:sldId id="417" r:id="rId6"/>
+    <p:sldId id="418" r:id="rId7"/>
+    <p:sldId id="419" r:id="rId8"/>
+    <p:sldId id="400" r:id="rId9"/>
   </p:sldIdLst>
   <p:sldSz cx="12192000" cy="6858000"/>
   <p:notesSz cx="6858000" cy="9144000"/>
@@ -261,7 +266,7 @@
           <a:p>
             <a:fld id="{3E102D2E-813C-461C-9963-687A650C48C0}" type="datetimeFigureOut">
               <a:rPr lang="en-US" smtClean="0"/>
-              <a:t>6/26/2025</a:t>
+              <a:t>8/9/2025</a:t>
             </a:fld>
             <a:endParaRPr lang="en-US"/>
           </a:p>
@@ -459,7 +464,7 @@
           <a:p>
             <a:fld id="{3E102D2E-813C-461C-9963-687A650C48C0}" type="datetimeFigureOut">
               <a:rPr lang="en-US" smtClean="0"/>
-              <a:t>6/26/2025</a:t>
+              <a:t>8/9/2025</a:t>
             </a:fld>
             <a:endParaRPr lang="en-US"/>
           </a:p>
@@ -667,7 +672,7 @@
           <a:p>
             <a:fld id="{3E102D2E-813C-461C-9963-687A650C48C0}" type="datetimeFigureOut">
               <a:rPr lang="en-US" smtClean="0"/>
-              <a:t>6/26/2025</a:t>
+              <a:t>8/9/2025</a:t>
             </a:fld>
             <a:endParaRPr lang="en-US"/>
           </a:p>
@@ -865,7 +870,7 @@
           <a:p>
             <a:fld id="{3E102D2E-813C-461C-9963-687A650C48C0}" type="datetimeFigureOut">
               <a:rPr lang="en-US" smtClean="0"/>
-              <a:t>6/26/2025</a:t>
+              <a:t>8/9/2025</a:t>
             </a:fld>
             <a:endParaRPr lang="en-US"/>
           </a:p>
@@ -1140,7 +1145,7 @@
           <a:p>
             <a:fld id="{3E102D2E-813C-461C-9963-687A650C48C0}" type="datetimeFigureOut">
               <a:rPr lang="en-US" smtClean="0"/>
-              <a:t>6/26/2025</a:t>
+              <a:t>8/9/2025</a:t>
             </a:fld>
             <a:endParaRPr lang="en-US"/>
           </a:p>
@@ -1405,7 +1410,7 @@
           <a:p>
             <a:fld id="{3E102D2E-813C-461C-9963-687A650C48C0}" type="datetimeFigureOut">
               <a:rPr lang="en-US" smtClean="0"/>
-              <a:t>6/26/2025</a:t>
+              <a:t>8/9/2025</a:t>
             </a:fld>
             <a:endParaRPr lang="en-US"/>
           </a:p>
@@ -1817,7 +1822,7 @@
           <a:p>
             <a:fld id="{3E102D2E-813C-461C-9963-687A650C48C0}" type="datetimeFigureOut">
               <a:rPr lang="en-US" smtClean="0"/>
-              <a:t>6/26/2025</a:t>
+              <a:t>8/9/2025</a:t>
             </a:fld>
             <a:endParaRPr lang="en-US"/>
           </a:p>
@@ -1958,7 +1963,7 @@
           <a:p>
             <a:fld id="{3E102D2E-813C-461C-9963-687A650C48C0}" type="datetimeFigureOut">
               <a:rPr lang="en-US" smtClean="0"/>
-              <a:t>6/26/2025</a:t>
+              <a:t>8/9/2025</a:t>
             </a:fld>
             <a:endParaRPr lang="en-US"/>
           </a:p>
@@ -2071,7 +2076,7 @@
           <a:p>
             <a:fld id="{3E102D2E-813C-461C-9963-687A650C48C0}" type="datetimeFigureOut">
               <a:rPr lang="en-US" smtClean="0"/>
-              <a:t>6/26/2025</a:t>
+              <a:t>8/9/2025</a:t>
             </a:fld>
             <a:endParaRPr lang="en-US"/>
           </a:p>
@@ -2382,7 +2387,7 @@
           <a:p>
             <a:fld id="{3E102D2E-813C-461C-9963-687A650C48C0}" type="datetimeFigureOut">
               <a:rPr lang="en-US" smtClean="0"/>
-              <a:t>6/26/2025</a:t>
+              <a:t>8/9/2025</a:t>
             </a:fld>
             <a:endParaRPr lang="en-US"/>
           </a:p>
@@ -2670,7 +2675,7 @@
           <a:p>
             <a:fld id="{3E102D2E-813C-461C-9963-687A650C48C0}" type="datetimeFigureOut">
               <a:rPr lang="en-US" smtClean="0"/>
-              <a:t>6/26/2025</a:t>
+              <a:t>8/9/2025</a:t>
             </a:fld>
             <a:endParaRPr lang="en-US"/>
           </a:p>
@@ -2911,7 +2916,7 @@
           <a:p>
             <a:fld id="{3E102D2E-813C-461C-9963-687A650C48C0}" type="datetimeFigureOut">
               <a:rPr lang="en-US" smtClean="0"/>
-              <a:t>6/26/2025</a:t>
+              <a:t>8/9/2025</a:t>
             </a:fld>
             <a:endParaRPr lang="en-US"/>
           </a:p>
@@ -3319,7 +3324,7 @@
         <p:cNvPr id="1" name="">
           <a:extLst>
             <a:ext uri="{FF2B5EF4-FFF2-40B4-BE49-F238E27FC236}">
-              <a16:creationId xmlns:a16="http://schemas.microsoft.com/office/drawing/2014/main" id="{6A435CBA-29A4-BFD2-CEA7-3290D85ED9F8}"/>
+              <a16:creationId xmlns:a16="http://schemas.microsoft.com/office/drawing/2014/main" id="{E0B23C97-7391-808C-8F93-F1A247B54F0E}"/>
             </a:ext>
           </a:extLst>
         </p:cNvPr>
@@ -3339,7 +3344,7 @@
           <p:cNvPr id="3" name="TextBox 2">
             <a:extLst>
               <a:ext uri="{FF2B5EF4-FFF2-40B4-BE49-F238E27FC236}">
-                <a16:creationId xmlns:a16="http://schemas.microsoft.com/office/drawing/2014/main" id="{A727ABBC-76D0-B81B-760F-26FC272AF479}"/>
+                <a16:creationId xmlns:a16="http://schemas.microsoft.com/office/drawing/2014/main" id="{D9BA728D-9AF8-6C25-DF35-1494919186BC}"/>
               </a:ext>
             </a:extLst>
           </p:cNvPr>
@@ -3348,8 +3353,8 @@
         </p:nvSpPr>
         <p:spPr>
           <a:xfrm>
-            <a:off x="217714" y="255046"/>
-            <a:ext cx="11756571" cy="355354"/>
+            <a:off x="217715" y="255046"/>
+            <a:ext cx="2636322" cy="355354"/>
           </a:xfrm>
           <a:prstGeom prst="rect">
             <a:avLst/>
@@ -3369,25 +3374,70 @@
               <a:buNone/>
             </a:pPr>
             <a:r>
-              <a:rPr kumimoji="0" lang="en-US" altLang="en-US" sz="1300" b="0" i="0" u="none" strike="noStrike" cap="none" normalizeH="0" baseline="0">
-                <a:ln>
-                  <a:noFill/>
-                </a:ln>
-                <a:solidFill>
-                  <a:schemeClr val="tx1"/>
-                </a:solidFill>
-                <a:effectLst/>
+              <a:rPr lang="az-Latn-AZ" altLang="en-US" sz="1300">
                 <a:latin typeface="Arial" panose="020B0604020202020204" pitchFamily="34" charset="0"/>
               </a:rPr>
-              <a:t>.</a:t>
-            </a:r>
-          </a:p>
-        </p:txBody>
-      </p:sp>
+              <a:t>Bu dərs bəzi hissələri </a:t>
+            </a:r>
+            <a:r>
+              <a:rPr lang="az-Latn-AZ" altLang="en-US" sz="1300" b="1">
+                <a:latin typeface="Arial" panose="020B0604020202020204" pitchFamily="34" charset="0"/>
+              </a:rPr>
+              <a:t>fix</a:t>
+            </a:r>
+            <a:r>
+              <a:rPr lang="az-Latn-AZ" altLang="en-US" sz="1300">
+                <a:latin typeface="Arial" panose="020B0604020202020204" pitchFamily="34" charset="0"/>
+              </a:rPr>
+              <a:t> edirik.</a:t>
+            </a:r>
+            <a:endParaRPr kumimoji="0" lang="en-US" altLang="en-US" sz="1300" b="0" i="0" u="none" strike="noStrike" cap="none" normalizeH="0" baseline="0">
+              <a:ln>
+                <a:noFill/>
+              </a:ln>
+              <a:solidFill>
+                <a:schemeClr val="tx1"/>
+              </a:solidFill>
+              <a:effectLst/>
+              <a:latin typeface="Arial" panose="020B0604020202020204" pitchFamily="34" charset="0"/>
+            </a:endParaRPr>
+          </a:p>
+        </p:txBody>
+      </p:sp>
+      <p:pic>
+        <p:nvPicPr>
+          <p:cNvPr id="4" name="Picture 3">
+            <a:extLst>
+              <a:ext uri="{FF2B5EF4-FFF2-40B4-BE49-F238E27FC236}">
+                <a16:creationId xmlns:a16="http://schemas.microsoft.com/office/drawing/2014/main" id="{513409CB-60EB-BF8A-7A8D-E20CAD9A01E7}"/>
+              </a:ext>
+            </a:extLst>
+          </p:cNvPr>
+          <p:cNvPicPr>
+            <a:picLocks noChangeAspect="1"/>
+          </p:cNvPicPr>
+          <p:nvPr/>
+        </p:nvPicPr>
+        <p:blipFill>
+          <a:blip r:embed="rId2"/>
+          <a:stretch>
+            <a:fillRect/>
+          </a:stretch>
+        </p:blipFill>
+        <p:spPr>
+          <a:xfrm>
+            <a:off x="3066719" y="0"/>
+            <a:ext cx="9125281" cy="6858000"/>
+          </a:xfrm>
+          <a:prstGeom prst="rect">
+            <a:avLst/>
+          </a:prstGeom>
+        </p:spPr>
+      </p:pic>
     </p:spTree>
     <p:extLst>
       <p:ext uri="{BB962C8B-B14F-4D97-AF65-F5344CB8AC3E}">
-        <p14:creationId xmlns:p14="http://schemas.microsoft.com/office/powerpoint/2010/main" val="3863838039"/>
+        <p14:creationId xmlns:p14="http://schemas.microsoft.com/office/powerpoint/2010/main" val="4233252692"/>
       </p:ext>
     </p:extLst>
   </p:cSld>
@@ -3405,7 +3455,7 @@
         <p:cNvPr id="1" name="">
           <a:extLst>
             <a:ext uri="{FF2B5EF4-FFF2-40B4-BE49-F238E27FC236}">
-              <a16:creationId xmlns:a16="http://schemas.microsoft.com/office/drawing/2014/main" id="{E0B23C97-7391-808C-8F93-F1A247B54F0E}"/>
+              <a16:creationId xmlns:a16="http://schemas.microsoft.com/office/drawing/2014/main" id="{6A435CBA-29A4-BFD2-CEA7-3290D85ED9F8}"/>
             </a:ext>
           </a:extLst>
         </p:cNvPr>
@@ -3425,7 +3475,468 @@
           <p:cNvPr id="3" name="TextBox 2">
             <a:extLst>
               <a:ext uri="{FF2B5EF4-FFF2-40B4-BE49-F238E27FC236}">
-                <a16:creationId xmlns:a16="http://schemas.microsoft.com/office/drawing/2014/main" id="{D9BA728D-9AF8-6C25-DF35-1494919186BC}"/>
+                <a16:creationId xmlns:a16="http://schemas.microsoft.com/office/drawing/2014/main" id="{A727ABBC-76D0-B81B-760F-26FC272AF479}"/>
+              </a:ext>
+            </a:extLst>
+          </p:cNvPr>
+          <p:cNvSpPr txBox="1"/>
+          <p:nvPr/>
+        </p:nvSpPr>
+        <p:spPr>
+          <a:xfrm>
+            <a:off x="217714" y="255046"/>
+            <a:ext cx="11756571" cy="1255600"/>
+          </a:xfrm>
+          <a:prstGeom prst="rect">
+            <a:avLst/>
+          </a:prstGeom>
+          <a:noFill/>
+        </p:spPr>
+        <p:txBody>
+          <a:bodyPr wrap="square">
+            <a:spAutoFit/>
+          </a:bodyPr>
+          <a:lstStyle/>
+          <a:p>
+            <a:pPr>
+              <a:lnSpc>
+                <a:spcPct val="150000"/>
+              </a:lnSpc>
+              <a:buNone/>
+            </a:pPr>
+            <a:r>
+              <a:rPr lang="az-Latn-AZ" altLang="en-US" sz="1300">
+                <a:latin typeface="Arial" panose="020B0604020202020204" pitchFamily="34" charset="0"/>
+              </a:rPr>
+              <a:t>Səhifə hər dəfə yeniləndikdə ekranın ortasında, yüklənməni ifadə edən həm </a:t>
+            </a:r>
+            <a:r>
+              <a:rPr lang="az-Latn-AZ" altLang="en-US" sz="1300" b="1">
+                <a:latin typeface="Arial" panose="020B0604020202020204" pitchFamily="34" charset="0"/>
+              </a:rPr>
+              <a:t>qara</a:t>
+            </a:r>
+            <a:r>
+              <a:rPr lang="az-Latn-AZ" altLang="en-US" sz="1300">
+                <a:latin typeface="Arial" panose="020B0604020202020204" pitchFamily="34" charset="0"/>
+              </a:rPr>
+              <a:t> rəngdə </a:t>
+            </a:r>
+            <a:r>
+              <a:rPr lang="az-Latn-AZ" altLang="en-US" sz="1300" b="1">
+                <a:latin typeface="Arial" panose="020B0604020202020204" pitchFamily="34" charset="0"/>
+              </a:rPr>
+              <a:t>spinner</a:t>
+            </a:r>
+            <a:r>
+              <a:rPr lang="az-Latn-AZ" altLang="en-US" sz="1300">
+                <a:latin typeface="Arial" panose="020B0604020202020204" pitchFamily="34" charset="0"/>
+              </a:rPr>
+              <a:t> həm də </a:t>
+            </a:r>
+            <a:r>
+              <a:rPr lang="az-Latn-AZ" altLang="en-US" sz="1300" b="1">
+                <a:latin typeface="Arial" panose="020B0604020202020204" pitchFamily="34" charset="0"/>
+              </a:rPr>
+              <a:t>göy</a:t>
+            </a:r>
+            <a:r>
+              <a:rPr lang="az-Latn-AZ" altLang="en-US" sz="1300">
+                <a:latin typeface="Arial" panose="020B0604020202020204" pitchFamily="34" charset="0"/>
+              </a:rPr>
+              <a:t> rəngdə </a:t>
+            </a:r>
+            <a:r>
+              <a:rPr lang="az-Latn-AZ" altLang="en-US" sz="1300" b="1">
+                <a:latin typeface="Arial" panose="020B0604020202020204" pitchFamily="34" charset="0"/>
+              </a:rPr>
+              <a:t>spinner</a:t>
+            </a:r>
+            <a:r>
+              <a:rPr lang="az-Latn-AZ" altLang="en-US" sz="1300">
+                <a:latin typeface="Arial" panose="020B0604020202020204" pitchFamily="34" charset="0"/>
+              </a:rPr>
+              <a:t> görsənir. Məsələn qara rəngli spinneri itirmək üçün ilk öncə həmin elementin CSS kodunu tapmaq lazımdır. </a:t>
+            </a:r>
+          </a:p>
+          <a:p>
+            <a:pPr>
+              <a:lnSpc>
+                <a:spcPct val="150000"/>
+              </a:lnSpc>
+              <a:buNone/>
+            </a:pPr>
+            <a:endParaRPr kumimoji="0" lang="az-Latn-AZ" altLang="en-US" sz="1300" b="0" i="0" u="none" strike="noStrike" cap="none" normalizeH="0" baseline="0">
+              <a:ln>
+                <a:noFill/>
+              </a:ln>
+              <a:solidFill>
+                <a:schemeClr val="tx1"/>
+              </a:solidFill>
+              <a:effectLst/>
+              <a:latin typeface="Arial" panose="020B0604020202020204" pitchFamily="34" charset="0"/>
+            </a:endParaRPr>
+          </a:p>
+          <a:p>
+            <a:pPr>
+              <a:lnSpc>
+                <a:spcPct val="150000"/>
+              </a:lnSpc>
+              <a:buNone/>
+            </a:pPr>
+            <a:r>
+              <a:rPr lang="az-Latn-AZ" altLang="en-US" sz="1300">
+                <a:latin typeface="Arial" panose="020B0604020202020204" pitchFamily="34" charset="0"/>
+              </a:rPr>
+              <a:t>Bu </a:t>
+            </a:r>
+            <a:endParaRPr kumimoji="0" lang="en-US" altLang="en-US" sz="1300" b="0" i="0" u="none" strike="noStrike" cap="none" normalizeH="0" baseline="0">
+              <a:ln>
+                <a:noFill/>
+              </a:ln>
+              <a:solidFill>
+                <a:schemeClr val="tx1"/>
+              </a:solidFill>
+              <a:effectLst/>
+              <a:latin typeface="Arial" panose="020B0604020202020204" pitchFamily="34" charset="0"/>
+            </a:endParaRPr>
+          </a:p>
+        </p:txBody>
+      </p:sp>
+      <p:pic>
+        <p:nvPicPr>
+          <p:cNvPr id="4" name="Picture 3">
+            <a:extLst>
+              <a:ext uri="{FF2B5EF4-FFF2-40B4-BE49-F238E27FC236}">
+                <a16:creationId xmlns:a16="http://schemas.microsoft.com/office/drawing/2014/main" id="{C6E2BB34-EB11-F97C-A278-90595C0EB2ED}"/>
+              </a:ext>
+            </a:extLst>
+          </p:cNvPr>
+          <p:cNvPicPr>
+            <a:picLocks noChangeAspect="1"/>
+          </p:cNvPicPr>
+          <p:nvPr/>
+        </p:nvPicPr>
+        <p:blipFill>
+          <a:blip r:embed="rId2"/>
+          <a:stretch>
+            <a:fillRect/>
+          </a:stretch>
+        </p:blipFill>
+        <p:spPr>
+          <a:xfrm>
+            <a:off x="83127" y="1691933"/>
+            <a:ext cx="12192000" cy="4637915"/>
+          </a:xfrm>
+          <a:prstGeom prst="rect">
+            <a:avLst/>
+          </a:prstGeom>
+        </p:spPr>
+      </p:pic>
+    </p:spTree>
+    <p:extLst>
+      <p:ext uri="{BB962C8B-B14F-4D97-AF65-F5344CB8AC3E}">
+        <p14:creationId xmlns:p14="http://schemas.microsoft.com/office/powerpoint/2010/main" val="3863838039"/>
+      </p:ext>
+    </p:extLst>
+  </p:cSld>
+  <p:clrMapOvr>
+    <a:masterClrMapping/>
+  </p:clrMapOvr>
+</p:sld>
+</file>
+
+<file path=ppt/slides/slide3.xml><?xml version="1.0" encoding="utf-8"?>
+<p:sld xmlns:a="http://schemas.openxmlformats.org/drawingml/2006/main" xmlns:r="http://schemas.openxmlformats.org/officeDocument/2006/relationships" xmlns:p="http://schemas.openxmlformats.org/presentationml/2006/main">
+  <p:cSld>
+    <p:spTree>
+      <p:nvGrpSpPr>
+        <p:cNvPr id="1" name="">
+          <a:extLst>
+            <a:ext uri="{FF2B5EF4-FFF2-40B4-BE49-F238E27FC236}">
+              <a16:creationId xmlns:a16="http://schemas.microsoft.com/office/drawing/2014/main" id="{1C09F43A-3E4F-26EE-3A09-22C0A3862920}"/>
+            </a:ext>
+          </a:extLst>
+        </p:cNvPr>
+        <p:cNvGrpSpPr/>
+        <p:nvPr/>
+      </p:nvGrpSpPr>
+      <p:grpSpPr>
+        <a:xfrm>
+          <a:off x="0" y="0"/>
+          <a:ext cx="0" cy="0"/>
+          <a:chOff x="0" y="0"/>
+          <a:chExt cx="0" cy="0"/>
+        </a:xfrm>
+      </p:grpSpPr>
+      <p:sp>
+        <p:nvSpPr>
+          <p:cNvPr id="3" name="TextBox 2">
+            <a:extLst>
+              <a:ext uri="{FF2B5EF4-FFF2-40B4-BE49-F238E27FC236}">
+                <a16:creationId xmlns:a16="http://schemas.microsoft.com/office/drawing/2014/main" id="{A0D34584-6539-F1A8-0D15-B3136433DE52}"/>
+              </a:ext>
+            </a:extLst>
+          </p:cNvPr>
+          <p:cNvSpPr txBox="1"/>
+          <p:nvPr/>
+        </p:nvSpPr>
+        <p:spPr>
+          <a:xfrm>
+            <a:off x="217714" y="88792"/>
+            <a:ext cx="11756571" cy="355354"/>
+          </a:xfrm>
+          <a:prstGeom prst="rect">
+            <a:avLst/>
+          </a:prstGeom>
+          <a:noFill/>
+        </p:spPr>
+        <p:txBody>
+          <a:bodyPr wrap="square">
+            <a:spAutoFit/>
+          </a:bodyPr>
+          <a:lstStyle/>
+          <a:p>
+            <a:pPr>
+              <a:lnSpc>
+                <a:spcPct val="150000"/>
+              </a:lnSpc>
+              <a:buNone/>
+            </a:pPr>
+            <a:r>
+              <a:rPr lang="az-Latn-AZ" altLang="en-US" sz="1300">
+                <a:latin typeface="Arial" panose="020B0604020202020204" pitchFamily="34" charset="0"/>
+              </a:rPr>
+              <a:t>Həmin </a:t>
+            </a:r>
+            <a:r>
+              <a:rPr lang="az-Latn-AZ" altLang="en-US" sz="1300" b="1">
+                <a:latin typeface="Arial" panose="020B0604020202020204" pitchFamily="34" charset="0"/>
+              </a:rPr>
+              <a:t>spinneri</a:t>
+            </a:r>
+            <a:r>
+              <a:rPr lang="az-Latn-AZ" altLang="en-US" sz="1300">
+                <a:latin typeface="Arial" panose="020B0604020202020204" pitchFamily="34" charset="0"/>
+              </a:rPr>
+              <a:t> ifadə edən </a:t>
+            </a:r>
+            <a:r>
+              <a:rPr lang="az-Latn-AZ" altLang="en-US" sz="1300" b="1">
+                <a:latin typeface="Arial" panose="020B0604020202020204" pitchFamily="34" charset="0"/>
+              </a:rPr>
+              <a:t>element</a:t>
+            </a:r>
+            <a:r>
+              <a:rPr lang="az-Latn-AZ" altLang="en-US" sz="1300">
+                <a:latin typeface="Arial" panose="020B0604020202020204" pitchFamily="34" charset="0"/>
+              </a:rPr>
+              <a:t> şəkildə işarətlənən elementdir. Bunun CSS kodunu sildikdə, artıq səhifə yenilənsə belə qara spinneri görməyəcəyik.</a:t>
+            </a:r>
+            <a:endParaRPr kumimoji="0" lang="en-US" altLang="en-US" sz="1300" b="0" i="0" u="none" strike="noStrike" cap="none" normalizeH="0" baseline="0">
+              <a:ln>
+                <a:noFill/>
+              </a:ln>
+              <a:solidFill>
+                <a:schemeClr val="tx1"/>
+              </a:solidFill>
+              <a:effectLst/>
+              <a:latin typeface="Arial" panose="020B0604020202020204" pitchFamily="34" charset="0"/>
+            </a:endParaRPr>
+          </a:p>
+        </p:txBody>
+      </p:sp>
+      <p:pic>
+        <p:nvPicPr>
+          <p:cNvPr id="4" name="Picture 3">
+            <a:extLst>
+              <a:ext uri="{FF2B5EF4-FFF2-40B4-BE49-F238E27FC236}">
+                <a16:creationId xmlns:a16="http://schemas.microsoft.com/office/drawing/2014/main" id="{277A7C1B-4931-2FC3-A525-887A7D6BEAC4}"/>
+              </a:ext>
+            </a:extLst>
+          </p:cNvPr>
+          <p:cNvPicPr>
+            <a:picLocks noChangeAspect="1"/>
+          </p:cNvPicPr>
+          <p:nvPr/>
+        </p:nvPicPr>
+        <p:blipFill>
+          <a:blip r:embed="rId2"/>
+          <a:stretch>
+            <a:fillRect/>
+          </a:stretch>
+        </p:blipFill>
+        <p:spPr>
+          <a:xfrm>
+            <a:off x="0" y="542811"/>
+            <a:ext cx="12192000" cy="6315189"/>
+          </a:xfrm>
+          <a:prstGeom prst="rect">
+            <a:avLst/>
+          </a:prstGeom>
+        </p:spPr>
+      </p:pic>
+    </p:spTree>
+    <p:extLst>
+      <p:ext uri="{BB962C8B-B14F-4D97-AF65-F5344CB8AC3E}">
+        <p14:creationId xmlns:p14="http://schemas.microsoft.com/office/powerpoint/2010/main" val="830529734"/>
+      </p:ext>
+    </p:extLst>
+  </p:cSld>
+  <p:clrMapOvr>
+    <a:masterClrMapping/>
+  </p:clrMapOvr>
+</p:sld>
+</file>
+
+<file path=ppt/slides/slide4.xml><?xml version="1.0" encoding="utf-8"?>
+<p:sld xmlns:a="http://schemas.openxmlformats.org/drawingml/2006/main" xmlns:r="http://schemas.openxmlformats.org/officeDocument/2006/relationships" xmlns:p="http://schemas.openxmlformats.org/presentationml/2006/main">
+  <p:cSld>
+    <p:spTree>
+      <p:nvGrpSpPr>
+        <p:cNvPr id="1" name="">
+          <a:extLst>
+            <a:ext uri="{FF2B5EF4-FFF2-40B4-BE49-F238E27FC236}">
+              <a16:creationId xmlns:a16="http://schemas.microsoft.com/office/drawing/2014/main" id="{0DA75BDE-3236-E41F-6077-DCD6235E3E99}"/>
+            </a:ext>
+          </a:extLst>
+        </p:cNvPr>
+        <p:cNvGrpSpPr/>
+        <p:nvPr/>
+      </p:nvGrpSpPr>
+      <p:grpSpPr>
+        <a:xfrm>
+          <a:off x="0" y="0"/>
+          <a:ext cx="0" cy="0"/>
+          <a:chOff x="0" y="0"/>
+          <a:chExt cx="0" cy="0"/>
+        </a:xfrm>
+      </p:grpSpPr>
+      <p:sp>
+        <p:nvSpPr>
+          <p:cNvPr id="3" name="TextBox 2">
+            <a:extLst>
+              <a:ext uri="{FF2B5EF4-FFF2-40B4-BE49-F238E27FC236}">
+                <a16:creationId xmlns:a16="http://schemas.microsoft.com/office/drawing/2014/main" id="{FDE83562-DF03-5A6B-5678-D92A30FC70B9}"/>
+              </a:ext>
+            </a:extLst>
+          </p:cNvPr>
+          <p:cNvSpPr txBox="1"/>
+          <p:nvPr/>
+        </p:nvSpPr>
+        <p:spPr>
+          <a:xfrm>
+            <a:off x="217714" y="134973"/>
+            <a:ext cx="11756571" cy="355354"/>
+          </a:xfrm>
+          <a:prstGeom prst="rect">
+            <a:avLst/>
+          </a:prstGeom>
+          <a:noFill/>
+        </p:spPr>
+        <p:txBody>
+          <a:bodyPr wrap="square">
+            <a:spAutoFit/>
+          </a:bodyPr>
+          <a:lstStyle/>
+          <a:p>
+            <a:pPr>
+              <a:lnSpc>
+                <a:spcPct val="150000"/>
+              </a:lnSpc>
+              <a:buNone/>
+            </a:pPr>
+            <a:r>
+              <a:rPr lang="az-Latn-AZ" altLang="en-US" sz="1300">
+                <a:latin typeface="Arial" panose="020B0604020202020204" pitchFamily="34" charset="0"/>
+              </a:rPr>
+              <a:t>Elementin class adını kopyalayaraq şəkildəki kimi axtarışa veririk və tapılan css stilini silirik.</a:t>
+            </a:r>
+            <a:endParaRPr kumimoji="0" lang="en-US" altLang="en-US" sz="1300" b="0" i="0" u="none" strike="noStrike" cap="none" normalizeH="0" baseline="0">
+              <a:ln>
+                <a:noFill/>
+              </a:ln>
+              <a:solidFill>
+                <a:schemeClr val="tx1"/>
+              </a:solidFill>
+              <a:effectLst/>
+              <a:latin typeface="Arial" panose="020B0604020202020204" pitchFamily="34" charset="0"/>
+            </a:endParaRPr>
+          </a:p>
+        </p:txBody>
+      </p:sp>
+      <p:pic>
+        <p:nvPicPr>
+          <p:cNvPr id="4" name="Picture 3">
+            <a:extLst>
+              <a:ext uri="{FF2B5EF4-FFF2-40B4-BE49-F238E27FC236}">
+                <a16:creationId xmlns:a16="http://schemas.microsoft.com/office/drawing/2014/main" id="{8A507E00-902E-94ED-77CF-A60F2153862B}"/>
+              </a:ext>
+            </a:extLst>
+          </p:cNvPr>
+          <p:cNvPicPr>
+            <a:picLocks noChangeAspect="1"/>
+          </p:cNvPicPr>
+          <p:nvPr/>
+        </p:nvPicPr>
+        <p:blipFill>
+          <a:blip r:embed="rId2"/>
+          <a:stretch>
+            <a:fillRect/>
+          </a:stretch>
+        </p:blipFill>
+        <p:spPr>
+          <a:xfrm>
+            <a:off x="369454" y="589713"/>
+            <a:ext cx="11822545" cy="6268287"/>
+          </a:xfrm>
+          <a:prstGeom prst="rect">
+            <a:avLst/>
+          </a:prstGeom>
+        </p:spPr>
+      </p:pic>
+    </p:spTree>
+    <p:extLst>
+      <p:ext uri="{BB962C8B-B14F-4D97-AF65-F5344CB8AC3E}">
+        <p14:creationId xmlns:p14="http://schemas.microsoft.com/office/powerpoint/2010/main" val="2593034442"/>
+      </p:ext>
+    </p:extLst>
+  </p:cSld>
+  <p:clrMapOvr>
+    <a:masterClrMapping/>
+  </p:clrMapOvr>
+</p:sld>
+</file>
+
+<file path=ppt/slides/slide5.xml><?xml version="1.0" encoding="utf-8"?>
+<p:sld xmlns:a="http://schemas.openxmlformats.org/drawingml/2006/main" xmlns:r="http://schemas.openxmlformats.org/officeDocument/2006/relationships" xmlns:p="http://schemas.openxmlformats.org/presentationml/2006/main">
+  <p:cSld>
+    <p:spTree>
+      <p:nvGrpSpPr>
+        <p:cNvPr id="1" name="">
+          <a:extLst>
+            <a:ext uri="{FF2B5EF4-FFF2-40B4-BE49-F238E27FC236}">
+              <a16:creationId xmlns:a16="http://schemas.microsoft.com/office/drawing/2014/main" id="{FBB30C62-BB30-D58D-5E35-AEF03A0A88FD}"/>
+            </a:ext>
+          </a:extLst>
+        </p:cNvPr>
+        <p:cNvGrpSpPr/>
+        <p:nvPr/>
+      </p:nvGrpSpPr>
+      <p:grpSpPr>
+        <a:xfrm>
+          <a:off x="0" y="0"/>
+          <a:ext cx="0" cy="0"/>
+          <a:chOff x="0" y="0"/>
+          <a:chExt cx="0" cy="0"/>
+        </a:xfrm>
+      </p:grpSpPr>
+      <p:sp>
+        <p:nvSpPr>
+          <p:cNvPr id="3" name="TextBox 2">
+            <a:extLst>
+              <a:ext uri="{FF2B5EF4-FFF2-40B4-BE49-F238E27FC236}">
+                <a16:creationId xmlns:a16="http://schemas.microsoft.com/office/drawing/2014/main" id="{CA1CD4D5-DDC8-AC3F-33D1-FB89C0F4C628}"/>
               </a:ext>
             </a:extLst>
           </p:cNvPr>
@@ -3455,25 +3966,72 @@
               <a:buNone/>
             </a:pPr>
             <a:r>
-              <a:rPr kumimoji="0" lang="en-US" altLang="en-US" sz="1300" b="0" i="0" u="none" strike="noStrike" cap="none" normalizeH="0" baseline="0">
-                <a:ln>
-                  <a:noFill/>
-                </a:ln>
-                <a:solidFill>
-                  <a:schemeClr val="tx1"/>
-                </a:solidFill>
-                <a:effectLst/>
+              <a:rPr lang="az-Latn-AZ" altLang="en-US" sz="1300">
                 <a:latin typeface="Arial" panose="020B0604020202020204" pitchFamily="34" charset="0"/>
               </a:rPr>
-              <a:t>.</a:t>
-            </a:r>
-          </a:p>
-        </p:txBody>
-      </p:sp>
+              <a:t>Nəticə.</a:t>
+            </a:r>
+            <a:endParaRPr kumimoji="0" lang="en-US" altLang="en-US" sz="1300" b="0" i="0" u="none" strike="noStrike" cap="none" normalizeH="0" baseline="0">
+              <a:ln>
+                <a:noFill/>
+              </a:ln>
+              <a:solidFill>
+                <a:schemeClr val="tx1"/>
+              </a:solidFill>
+              <a:effectLst/>
+              <a:latin typeface="Arial" panose="020B0604020202020204" pitchFamily="34" charset="0"/>
+            </a:endParaRPr>
+          </a:p>
+        </p:txBody>
+      </p:sp>
+      <p:pic>
+        <p:nvPicPr>
+          <p:cNvPr id="4" name="Picture 3">
+            <a:extLst>
+              <a:ext uri="{FF2B5EF4-FFF2-40B4-BE49-F238E27FC236}">
+                <a16:creationId xmlns:a16="http://schemas.microsoft.com/office/drawing/2014/main" id="{1CC8C57A-0583-2BCE-B927-3C7A8A0B9E19}"/>
+              </a:ext>
+            </a:extLst>
+          </p:cNvPr>
+          <p:cNvPicPr>
+            <a:picLocks noChangeAspect="1"/>
+          </p:cNvPicPr>
+          <p:nvPr/>
+        </p:nvPicPr>
+        <p:blipFill>
+          <a:blip r:embed="rId2"/>
+          <a:stretch>
+            <a:fillRect/>
+          </a:stretch>
+        </p:blipFill>
+        <p:spPr>
+          <a:xfrm>
+            <a:off x="0" y="3057152"/>
+            <a:ext cx="12192000" cy="3800848"/>
+          </a:xfrm>
+          <a:prstGeom prst="rect">
+            <a:avLst/>
+          </a:prstGeom>
+          <a:ln w="38100" cap="sq">
+            <a:solidFill>
+              <a:srgbClr val="000000"/>
+            </a:solidFill>
+            <a:prstDash val="solid"/>
+            <a:miter lim="800000"/>
+          </a:ln>
+          <a:effectLst>
+            <a:outerShdw blurRad="50800" dist="38100" dir="2700000" algn="tl" rotWithShape="0">
+              <a:srgbClr val="000000">
+                <a:alpha val="43000"/>
+              </a:srgbClr>
+            </a:outerShdw>
+          </a:effectLst>
+        </p:spPr>
+      </p:pic>
     </p:spTree>
     <p:extLst>
       <p:ext uri="{BB962C8B-B14F-4D97-AF65-F5344CB8AC3E}">
-        <p14:creationId xmlns:p14="http://schemas.microsoft.com/office/powerpoint/2010/main" val="4233252692"/>
+        <p14:creationId xmlns:p14="http://schemas.microsoft.com/office/powerpoint/2010/main" val="38128841"/>
       </p:ext>
     </p:extLst>
   </p:cSld>
@@ -3483,7 +4041,311 @@
 </p:sld>
 </file>
 
-<file path=ppt/slides/slide3.xml><?xml version="1.0" encoding="utf-8"?>
+<file path=ppt/slides/slide6.xml><?xml version="1.0" encoding="utf-8"?>
+<p:sld xmlns:a="http://schemas.openxmlformats.org/drawingml/2006/main" xmlns:r="http://schemas.openxmlformats.org/officeDocument/2006/relationships" xmlns:p="http://schemas.openxmlformats.org/presentationml/2006/main">
+  <p:cSld>
+    <p:spTree>
+      <p:nvGrpSpPr>
+        <p:cNvPr id="1" name="">
+          <a:extLst>
+            <a:ext uri="{FF2B5EF4-FFF2-40B4-BE49-F238E27FC236}">
+              <a16:creationId xmlns:a16="http://schemas.microsoft.com/office/drawing/2014/main" id="{BF166923-79CB-30B6-4514-3710198043C3}"/>
+            </a:ext>
+          </a:extLst>
+        </p:cNvPr>
+        <p:cNvGrpSpPr/>
+        <p:nvPr/>
+      </p:nvGrpSpPr>
+      <p:grpSpPr>
+        <a:xfrm>
+          <a:off x="0" y="0"/>
+          <a:ext cx="0" cy="0"/>
+          <a:chOff x="0" y="0"/>
+          <a:chExt cx="0" cy="0"/>
+        </a:xfrm>
+      </p:grpSpPr>
+      <p:sp>
+        <p:nvSpPr>
+          <p:cNvPr id="3" name="TextBox 2">
+            <a:extLst>
+              <a:ext uri="{FF2B5EF4-FFF2-40B4-BE49-F238E27FC236}">
+                <a16:creationId xmlns:a16="http://schemas.microsoft.com/office/drawing/2014/main" id="{7C78AA9D-B19E-CB49-1F38-8530C78109CE}"/>
+              </a:ext>
+            </a:extLst>
+          </p:cNvPr>
+          <p:cNvSpPr txBox="1"/>
+          <p:nvPr/>
+        </p:nvSpPr>
+        <p:spPr>
+          <a:xfrm>
+            <a:off x="110836" y="92709"/>
+            <a:ext cx="11933382" cy="655436"/>
+          </a:xfrm>
+          <a:prstGeom prst="rect">
+            <a:avLst/>
+          </a:prstGeom>
+          <a:noFill/>
+        </p:spPr>
+        <p:txBody>
+          <a:bodyPr wrap="square">
+            <a:spAutoFit/>
+          </a:bodyPr>
+          <a:lstStyle/>
+          <a:p>
+            <a:pPr>
+              <a:lnSpc>
+                <a:spcPct val="150000"/>
+              </a:lnSpc>
+              <a:buNone/>
+            </a:pPr>
+            <a:r>
+              <a:rPr lang="az-Latn-AZ" altLang="en-US" sz="1300">
+                <a:latin typeface="Arial" panose="020B0604020202020204" pitchFamily="34" charset="0"/>
+              </a:rPr>
+              <a:t>Cədvəldə görsənəcək </a:t>
+            </a:r>
+            <a:r>
+              <a:rPr lang="az-Latn-AZ" altLang="en-US" sz="1300" b="1">
+                <a:solidFill>
+                  <a:srgbClr val="FF0000"/>
+                </a:solidFill>
+                <a:latin typeface="Arial" panose="020B0604020202020204" pitchFamily="34" charset="0"/>
+              </a:rPr>
+              <a:t>serial</a:t>
+            </a:r>
+            <a:r>
+              <a:rPr lang="az-Latn-AZ" altLang="en-US" sz="1300">
+                <a:latin typeface="Arial" panose="020B0604020202020204" pitchFamily="34" charset="0"/>
+              </a:rPr>
+              <a:t> və </a:t>
+            </a:r>
+            <a:r>
+              <a:rPr lang="az-Latn-AZ" altLang="en-US" sz="1300" b="1">
+                <a:solidFill>
+                  <a:srgbClr val="FF0000"/>
+                </a:solidFill>
+                <a:latin typeface="Arial" panose="020B0604020202020204" pitchFamily="34" charset="0"/>
+              </a:rPr>
+              <a:t>status</a:t>
+            </a:r>
+            <a:r>
+              <a:rPr lang="az-Latn-AZ" altLang="en-US" sz="1300">
+                <a:latin typeface="Arial" panose="020B0604020202020204" pitchFamily="34" charset="0"/>
+              </a:rPr>
+              <a:t> sütunlarınıda əlavə edirik və şərt qoşaraq deyirik ki, əgər </a:t>
+            </a:r>
+            <a:r>
+              <a:rPr lang="az-Latn-AZ" altLang="en-US" sz="1300" b="1">
+                <a:latin typeface="Arial" panose="020B0604020202020204" pitchFamily="34" charset="0"/>
+              </a:rPr>
+              <a:t>status == 1 </a:t>
+            </a:r>
+            <a:r>
+              <a:rPr lang="az-Latn-AZ" altLang="en-US" sz="1300">
+                <a:latin typeface="Arial" panose="020B0604020202020204" pitchFamily="34" charset="0"/>
+              </a:rPr>
+              <a:t>olarsa </a:t>
+            </a:r>
+            <a:r>
+              <a:rPr lang="az-Latn-AZ" altLang="en-US" sz="1300" b="1">
+                <a:latin typeface="Arial" panose="020B0604020202020204" pitchFamily="34" charset="0"/>
+              </a:rPr>
+              <a:t>success</a:t>
+            </a:r>
+            <a:r>
+              <a:rPr lang="az-Latn-AZ" altLang="en-US" sz="1300">
+                <a:latin typeface="Arial" panose="020B0604020202020204" pitchFamily="34" charset="0"/>
+              </a:rPr>
+              <a:t> elementini, əks halda </a:t>
+            </a:r>
+            <a:r>
+              <a:rPr lang="az-Latn-AZ" altLang="en-US" sz="1300" b="1">
+                <a:latin typeface="Arial" panose="020B0604020202020204" pitchFamily="34" charset="0"/>
+              </a:rPr>
+              <a:t>danger</a:t>
+            </a:r>
+            <a:r>
+              <a:rPr lang="az-Latn-AZ" altLang="en-US" sz="1300">
+                <a:latin typeface="Arial" panose="020B0604020202020204" pitchFamily="34" charset="0"/>
+              </a:rPr>
+              <a:t> elementini göstər. </a:t>
+            </a:r>
+            <a:endParaRPr kumimoji="0" lang="en-US" altLang="en-US" sz="1300" b="0" i="0" u="none" strike="noStrike" cap="none" normalizeH="0" baseline="0">
+              <a:ln>
+                <a:noFill/>
+              </a:ln>
+              <a:solidFill>
+                <a:schemeClr val="tx1"/>
+              </a:solidFill>
+              <a:effectLst/>
+              <a:latin typeface="Arial" panose="020B0604020202020204" pitchFamily="34" charset="0"/>
+            </a:endParaRPr>
+          </a:p>
+        </p:txBody>
+      </p:sp>
+      <p:pic>
+        <p:nvPicPr>
+          <p:cNvPr id="4" name="Picture 3">
+            <a:extLst>
+              <a:ext uri="{FF2B5EF4-FFF2-40B4-BE49-F238E27FC236}">
+                <a16:creationId xmlns:a16="http://schemas.microsoft.com/office/drawing/2014/main" id="{08EB2149-516B-F150-C7B3-FBD598CD18CD}"/>
+              </a:ext>
+            </a:extLst>
+          </p:cNvPr>
+          <p:cNvPicPr>
+            <a:picLocks noChangeAspect="1"/>
+          </p:cNvPicPr>
+          <p:nvPr/>
+        </p:nvPicPr>
+        <p:blipFill>
+          <a:blip r:embed="rId2"/>
+          <a:stretch>
+            <a:fillRect/>
+          </a:stretch>
+        </p:blipFill>
+        <p:spPr>
+          <a:xfrm>
+            <a:off x="3409056" y="822036"/>
+            <a:ext cx="8782944" cy="6035964"/>
+          </a:xfrm>
+          <a:prstGeom prst="rect">
+            <a:avLst/>
+          </a:prstGeom>
+        </p:spPr>
+      </p:pic>
+    </p:spTree>
+    <p:extLst>
+      <p:ext uri="{BB962C8B-B14F-4D97-AF65-F5344CB8AC3E}">
+        <p14:creationId xmlns:p14="http://schemas.microsoft.com/office/powerpoint/2010/main" val="2977799795"/>
+      </p:ext>
+    </p:extLst>
+  </p:cSld>
+  <p:clrMapOvr>
+    <a:masterClrMapping/>
+  </p:clrMapOvr>
+</p:sld>
+</file>
+
+<file path=ppt/slides/slide7.xml><?xml version="1.0" encoding="utf-8"?>
+<p:sld xmlns:a="http://schemas.openxmlformats.org/drawingml/2006/main" xmlns:r="http://schemas.openxmlformats.org/officeDocument/2006/relationships" xmlns:p="http://schemas.openxmlformats.org/presentationml/2006/main">
+  <p:cSld>
+    <p:spTree>
+      <p:nvGrpSpPr>
+        <p:cNvPr id="1" name="">
+          <a:extLst>
+            <a:ext uri="{FF2B5EF4-FFF2-40B4-BE49-F238E27FC236}">
+              <a16:creationId xmlns:a16="http://schemas.microsoft.com/office/drawing/2014/main" id="{02BB02DE-E787-B53D-8237-B42F2B66B0E3}"/>
+            </a:ext>
+          </a:extLst>
+        </p:cNvPr>
+        <p:cNvGrpSpPr/>
+        <p:nvPr/>
+      </p:nvGrpSpPr>
+      <p:grpSpPr>
+        <a:xfrm>
+          <a:off x="0" y="0"/>
+          <a:ext cx="0" cy="0"/>
+          <a:chOff x="0" y="0"/>
+          <a:chExt cx="0" cy="0"/>
+        </a:xfrm>
+      </p:grpSpPr>
+      <p:sp>
+        <p:nvSpPr>
+          <p:cNvPr id="3" name="TextBox 2">
+            <a:extLst>
+              <a:ext uri="{FF2B5EF4-FFF2-40B4-BE49-F238E27FC236}">
+                <a16:creationId xmlns:a16="http://schemas.microsoft.com/office/drawing/2014/main" id="{8DD6E2A6-F1E4-15AE-413D-6B1A1D7AB19E}"/>
+              </a:ext>
+            </a:extLst>
+          </p:cNvPr>
+          <p:cNvSpPr txBox="1"/>
+          <p:nvPr/>
+        </p:nvSpPr>
+        <p:spPr>
+          <a:xfrm>
+            <a:off x="217714" y="255046"/>
+            <a:ext cx="11756571" cy="355354"/>
+          </a:xfrm>
+          <a:prstGeom prst="rect">
+            <a:avLst/>
+          </a:prstGeom>
+          <a:noFill/>
+        </p:spPr>
+        <p:txBody>
+          <a:bodyPr wrap="square">
+            <a:spAutoFit/>
+          </a:bodyPr>
+          <a:lstStyle/>
+          <a:p>
+            <a:pPr>
+              <a:lnSpc>
+                <a:spcPct val="150000"/>
+              </a:lnSpc>
+              <a:buNone/>
+            </a:pPr>
+            <a:r>
+              <a:rPr lang="az-Latn-AZ" altLang="en-US" sz="1300">
+                <a:latin typeface="Arial" panose="020B0604020202020204" pitchFamily="34" charset="0"/>
+              </a:rPr>
+              <a:t>Nəticə.</a:t>
+            </a:r>
+            <a:endParaRPr kumimoji="0" lang="en-US" altLang="en-US" sz="1300" b="0" i="0" u="none" strike="noStrike" cap="none" normalizeH="0" baseline="0">
+              <a:ln>
+                <a:noFill/>
+              </a:ln>
+              <a:solidFill>
+                <a:schemeClr val="tx1"/>
+              </a:solidFill>
+              <a:effectLst/>
+              <a:latin typeface="Arial" panose="020B0604020202020204" pitchFamily="34" charset="0"/>
+            </a:endParaRPr>
+          </a:p>
+        </p:txBody>
+      </p:sp>
+      <p:pic>
+        <p:nvPicPr>
+          <p:cNvPr id="4" name="Picture 3">
+            <a:extLst>
+              <a:ext uri="{FF2B5EF4-FFF2-40B4-BE49-F238E27FC236}">
+                <a16:creationId xmlns:a16="http://schemas.microsoft.com/office/drawing/2014/main" id="{40F2F2F6-743D-4153-F880-5CF79D34E429}"/>
+              </a:ext>
+            </a:extLst>
+          </p:cNvPr>
+          <p:cNvPicPr>
+            <a:picLocks noChangeAspect="1"/>
+          </p:cNvPicPr>
+          <p:nvPr/>
+        </p:nvPicPr>
+        <p:blipFill>
+          <a:blip r:embed="rId2"/>
+          <a:stretch>
+            <a:fillRect/>
+          </a:stretch>
+        </p:blipFill>
+        <p:spPr>
+          <a:xfrm>
+            <a:off x="0" y="2246188"/>
+            <a:ext cx="12192000" cy="4611812"/>
+          </a:xfrm>
+          <a:prstGeom prst="rect">
+            <a:avLst/>
+          </a:prstGeom>
+        </p:spPr>
+      </p:pic>
+    </p:spTree>
+    <p:extLst>
+      <p:ext uri="{BB962C8B-B14F-4D97-AF65-F5344CB8AC3E}">
+        <p14:creationId xmlns:p14="http://schemas.microsoft.com/office/powerpoint/2010/main" val="2685650745"/>
+      </p:ext>
+    </p:extLst>
+  </p:cSld>
+  <p:clrMapOvr>
+    <a:masterClrMapping/>
+  </p:clrMapOvr>
+</p:sld>
+</file>
+
+<file path=ppt/slides/slide8.xml><?xml version="1.0" encoding="utf-8"?>
 <p:sld xmlns:a="http://schemas.openxmlformats.org/drawingml/2006/main" xmlns:r="http://schemas.openxmlformats.org/officeDocument/2006/relationships" xmlns:p="http://schemas.openxmlformats.org/presentationml/2006/main">
   <p:cSld>
     <p:spTree>

</xml_diff>